<commit_message>
Segundo commit del proyecto
</commit_message>
<xml_diff>
--- a/dist/plantilla-2pm.pptx
+++ b/dist/plantilla-2pm.pptx
@@ -255,7 +255,7 @@
           <a:p>
             <a:fld id="{631855BB-C5D2-4F82-B71B-CB3B65D6AB2E}" type="datetimeFigureOut">
               <a:rPr lang="es-ES" smtClean="0"/>
-              <a:t>08/03/2026</a:t>
+              <a:t>23/03/2026</a:t>
             </a:fld>
             <a:endParaRPr lang="es-ES"/>
           </a:p>
@@ -326,138 +326,6 @@
           <a:chExt cx="0" cy="0"/>
         </a:xfrm>
       </p:grpSpPr>
-      <p:sp>
-        <p:nvSpPr>
-          <p:cNvPr id="11" name="object 8">
-            <a:extLst>
-              <a:ext uri="{FF2B5EF4-FFF2-40B4-BE49-F238E27FC236}">
-                <a16:creationId xmlns:a16="http://schemas.microsoft.com/office/drawing/2014/main" id="{11F865FE-5386-4787-95C7-B13A153E4858}"/>
-              </a:ext>
-            </a:extLst>
-          </p:cNvPr>
-          <p:cNvSpPr txBox="1"/>
-          <p:nvPr userDrawn="1"/>
-        </p:nvSpPr>
-        <p:spPr>
-          <a:xfrm>
-            <a:off x="3795395" y="3337106"/>
-            <a:ext cx="4601210" cy="331470"/>
-          </a:xfrm>
-          <a:prstGeom prst="rect">
-            <a:avLst/>
-          </a:prstGeom>
-        </p:spPr>
-        <p:txBody>
-          <a:bodyPr vert="horz" wrap="square" lIns="0" tIns="13335" rIns="0" bIns="0" rtlCol="0">
-            <a:spAutoFit/>
-          </a:bodyPr>
-          <a:lstStyle/>
-          <a:p>
-            <a:pPr marL="12700" algn="ctr">
-              <a:lnSpc>
-                <a:spcPct val="100000"/>
-              </a:lnSpc>
-              <a:spcBef>
-                <a:spcPts val="105"/>
-              </a:spcBef>
-            </a:pPr>
-            <a:r>
-              <a:rPr sz="2000" dirty="0">
-                <a:solidFill>
-                  <a:srgbClr val="FFFFFF"/>
-                </a:solidFill>
-                <a:latin typeface="Calibri"/>
-                <a:cs typeface="Calibri"/>
-              </a:rPr>
-              <a:t>VP</a:t>
-            </a:r>
-            <a:r>
-              <a:rPr sz="2000" spc="150" dirty="0">
-                <a:solidFill>
-                  <a:srgbClr val="FFFFFF"/>
-                </a:solidFill>
-                <a:latin typeface="Calibri"/>
-                <a:cs typeface="Calibri"/>
-              </a:rPr>
-              <a:t> </a:t>
-            </a:r>
-            <a:r>
-              <a:rPr sz="2000" spc="55" dirty="0">
-                <a:solidFill>
-                  <a:srgbClr val="FFFFFF"/>
-                </a:solidFill>
-                <a:latin typeface="Calibri"/>
-                <a:cs typeface="Calibri"/>
-              </a:rPr>
-              <a:t>EMPRESAS</a:t>
-            </a:r>
-            <a:r>
-              <a:rPr sz="2000" spc="150" dirty="0">
-                <a:solidFill>
-                  <a:srgbClr val="FFFFFF"/>
-                </a:solidFill>
-                <a:latin typeface="Calibri"/>
-                <a:cs typeface="Calibri"/>
-              </a:rPr>
-              <a:t> </a:t>
-            </a:r>
-            <a:r>
-              <a:rPr sz="2000" dirty="0">
-                <a:solidFill>
-                  <a:srgbClr val="FFFFFF"/>
-                </a:solidFill>
-                <a:latin typeface="Calibri"/>
-                <a:cs typeface="Calibri"/>
-              </a:rPr>
-              <a:t>Y</a:t>
-            </a:r>
-            <a:r>
-              <a:rPr sz="2000" spc="150" dirty="0">
-                <a:solidFill>
-                  <a:srgbClr val="FFFFFF"/>
-                </a:solidFill>
-                <a:latin typeface="Calibri"/>
-                <a:cs typeface="Calibri"/>
-              </a:rPr>
-              <a:t> </a:t>
-            </a:r>
-            <a:r>
-              <a:rPr sz="2000" spc="55" dirty="0">
-                <a:solidFill>
-                  <a:srgbClr val="FFFFFF"/>
-                </a:solidFill>
-                <a:latin typeface="Calibri"/>
-                <a:cs typeface="Calibri"/>
-              </a:rPr>
-              <a:t>CIUDADES</a:t>
-            </a:r>
-            <a:r>
-              <a:rPr sz="2000" spc="125" dirty="0">
-                <a:solidFill>
-                  <a:srgbClr val="FFFFFF"/>
-                </a:solidFill>
-                <a:latin typeface="Calibri"/>
-                <a:cs typeface="Calibri"/>
-              </a:rPr>
-              <a:t> </a:t>
-            </a:r>
-            <a:r>
-              <a:rPr sz="2000" spc="50" dirty="0">
-                <a:solidFill>
-                  <a:srgbClr val="FFFFFF"/>
-                </a:solidFill>
-                <a:latin typeface="Calibri"/>
-                <a:cs typeface="Calibri"/>
-              </a:rPr>
-              <a:t>INTELIGENTES</a:t>
-            </a:r>
-            <a:endParaRPr sz="2000" dirty="0">
-              <a:latin typeface="Calibri"/>
-              <a:cs typeface="Calibri"/>
-            </a:endParaRPr>
-          </a:p>
-        </p:txBody>
-      </p:sp>
       <p:sp>
         <p:nvSpPr>
           <p:cNvPr id="14" name="Rectángulo 13">
@@ -671,6 +539,138 @@
                 <a:srgbClr val="FFFFFF"/>
               </a:solidFill>
               <a:latin typeface="Calibri" panose="020F0502020204030204" pitchFamily="34" charset="0"/>
+              <a:cs typeface="Calibri"/>
+            </a:endParaRPr>
+          </a:p>
+        </p:txBody>
+      </p:sp>
+      <p:sp>
+        <p:nvSpPr>
+          <p:cNvPr id="7" name="object 8">
+            <a:extLst>
+              <a:ext uri="{FF2B5EF4-FFF2-40B4-BE49-F238E27FC236}">
+                <a16:creationId xmlns:a16="http://schemas.microsoft.com/office/drawing/2014/main" id="{FCEA1E56-3FCA-42BA-ADE9-50D89689444C}"/>
+              </a:ext>
+            </a:extLst>
+          </p:cNvPr>
+          <p:cNvSpPr txBox="1"/>
+          <p:nvPr userDrawn="1"/>
+        </p:nvSpPr>
+        <p:spPr>
+          <a:xfrm>
+            <a:off x="3795395" y="2107329"/>
+            <a:ext cx="4601210" cy="331470"/>
+          </a:xfrm>
+          <a:prstGeom prst="rect">
+            <a:avLst/>
+          </a:prstGeom>
+        </p:spPr>
+        <p:txBody>
+          <a:bodyPr vert="horz" wrap="square" lIns="0" tIns="13335" rIns="0" bIns="0" rtlCol="0">
+            <a:spAutoFit/>
+          </a:bodyPr>
+          <a:lstStyle/>
+          <a:p>
+            <a:pPr marL="12700" algn="ctr">
+              <a:lnSpc>
+                <a:spcPct val="100000"/>
+              </a:lnSpc>
+              <a:spcBef>
+                <a:spcPts val="105"/>
+              </a:spcBef>
+            </a:pPr>
+            <a:r>
+              <a:rPr sz="2000" dirty="0">
+                <a:solidFill>
+                  <a:srgbClr val="FFFFFF"/>
+                </a:solidFill>
+                <a:latin typeface="Calibri"/>
+                <a:cs typeface="Calibri"/>
+              </a:rPr>
+              <a:t>VP</a:t>
+            </a:r>
+            <a:r>
+              <a:rPr sz="2000" spc="150" dirty="0">
+                <a:solidFill>
+                  <a:srgbClr val="FFFFFF"/>
+                </a:solidFill>
+                <a:latin typeface="Calibri"/>
+                <a:cs typeface="Calibri"/>
+              </a:rPr>
+              <a:t> </a:t>
+            </a:r>
+            <a:r>
+              <a:rPr sz="2000" spc="55" dirty="0">
+                <a:solidFill>
+                  <a:srgbClr val="FFFFFF"/>
+                </a:solidFill>
+                <a:latin typeface="Calibri"/>
+                <a:cs typeface="Calibri"/>
+              </a:rPr>
+              <a:t>EMPRESAS</a:t>
+            </a:r>
+            <a:r>
+              <a:rPr sz="2000" spc="150" dirty="0">
+                <a:solidFill>
+                  <a:srgbClr val="FFFFFF"/>
+                </a:solidFill>
+                <a:latin typeface="Calibri"/>
+                <a:cs typeface="Calibri"/>
+              </a:rPr>
+              <a:t> </a:t>
+            </a:r>
+            <a:r>
+              <a:rPr sz="2000" dirty="0">
+                <a:solidFill>
+                  <a:srgbClr val="FFFFFF"/>
+                </a:solidFill>
+                <a:latin typeface="Calibri"/>
+                <a:cs typeface="Calibri"/>
+              </a:rPr>
+              <a:t>Y</a:t>
+            </a:r>
+            <a:r>
+              <a:rPr sz="2000" spc="150" dirty="0">
+                <a:solidFill>
+                  <a:srgbClr val="FFFFFF"/>
+                </a:solidFill>
+                <a:latin typeface="Calibri"/>
+                <a:cs typeface="Calibri"/>
+              </a:rPr>
+              <a:t> </a:t>
+            </a:r>
+            <a:r>
+              <a:rPr sz="2000" spc="55" dirty="0">
+                <a:solidFill>
+                  <a:srgbClr val="FFFFFF"/>
+                </a:solidFill>
+                <a:latin typeface="Calibri"/>
+                <a:cs typeface="Calibri"/>
+              </a:rPr>
+              <a:t>CIUDADES</a:t>
+            </a:r>
+            <a:r>
+              <a:rPr sz="2000" spc="125" dirty="0">
+                <a:solidFill>
+                  <a:srgbClr val="FFFFFF"/>
+                </a:solidFill>
+                <a:latin typeface="Calibri"/>
+                <a:cs typeface="Calibri"/>
+              </a:rPr>
+              <a:t> </a:t>
+            </a:r>
+            <a:r>
+              <a:rPr sz="2000" spc="50" dirty="0">
+                <a:solidFill>
+                  <a:srgbClr val="FFFFFF"/>
+                </a:solidFill>
+                <a:latin typeface="Calibri"/>
+                <a:cs typeface="Calibri"/>
+              </a:rPr>
+              <a:t>INTELIGENTES</a:t>
+            </a:r>
+            <a:endParaRPr sz="2000" dirty="0">
+              <a:latin typeface="Calibri"/>
               <a:cs typeface="Calibri"/>
             </a:endParaRPr>
           </a:p>
@@ -2796,54 +2796,6 @@
       </p:pic>
       <p:sp>
         <p:nvSpPr>
-          <p:cNvPr id="10" name="img-Marco-D14">
-            <a:extLst>
-              <a:ext uri="{FF2B5EF4-FFF2-40B4-BE49-F238E27FC236}">
-                <a16:creationId xmlns:a16="http://schemas.microsoft.com/office/drawing/2014/main" id="{C13427B4-A0AF-48F9-9BD8-B9DFE2F16E68}"/>
-              </a:ext>
-            </a:extLst>
-          </p:cNvPr>
-          <p:cNvSpPr/>
-          <p:nvPr userDrawn="1"/>
-        </p:nvSpPr>
-        <p:spPr>
-          <a:xfrm>
-            <a:off x="3231154" y="1896427"/>
-            <a:ext cx="5729692" cy="3065146"/>
-          </a:xfrm>
-          <a:prstGeom prst="rect">
-            <a:avLst/>
-          </a:prstGeom>
-          <a:noFill/>
-          <a:ln>
-            <a:noFill/>
-          </a:ln>
-        </p:spPr>
-        <p:style>
-          <a:lnRef idx="0">
-            <a:scrgbClr r="0" g="0" b="0"/>
-          </a:lnRef>
-          <a:fillRef idx="0">
-            <a:scrgbClr r="0" g="0" b="0"/>
-          </a:fillRef>
-          <a:effectRef idx="0">
-            <a:scrgbClr r="0" g="0" b="0"/>
-          </a:effectRef>
-          <a:fontRef idx="minor">
-            <a:schemeClr val="accent2"/>
-          </a:fontRef>
-        </p:style>
-        <p:txBody>
-          <a:bodyPr rtlCol="0" anchor="ctr"/>
-          <a:lstStyle/>
-          <a:p>
-            <a:pPr algn="ctr"/>
-            <a:endParaRPr lang="es-ES" dirty="0"/>
-          </a:p>
-        </p:txBody>
-      </p:sp>
-      <p:sp>
-        <p:nvSpPr>
           <p:cNvPr id="11" name="RedNuse-14">
             <a:extLst>
               <a:ext uri="{FF2B5EF4-FFF2-40B4-BE49-F238E27FC236}">
@@ -3166,8 +3118,8 @@
         </p:nvSpPr>
         <p:spPr>
           <a:xfrm>
-            <a:off x="3565580" y="5296933"/>
-            <a:ext cx="5055596" cy="584775"/>
+            <a:off x="3873131" y="5296933"/>
+            <a:ext cx="4445738" cy="584775"/>
           </a:xfrm>
           <a:prstGeom prst="rect">
             <a:avLst/>
@@ -12234,77 +12186,6 @@
               </a:solidFill>
               <a:latin typeface="Calibri"/>
               <a:cs typeface="Calibri"/>
-            </a:endParaRPr>
-          </a:p>
-        </p:txBody>
-      </p:sp>
-      <p:sp>
-        <p:nvSpPr>
-          <p:cNvPr id="9" name="15-Novedades">
-            <a:extLst>
-              <a:ext uri="{FF2B5EF4-FFF2-40B4-BE49-F238E27FC236}">
-                <a16:creationId xmlns:a16="http://schemas.microsoft.com/office/drawing/2014/main" id="{9DAD8D5B-3F11-41C2-B169-2F569B07359E}"/>
-              </a:ext>
-            </a:extLst>
-          </p:cNvPr>
-          <p:cNvSpPr txBox="1">
-            <a:spLocks noGrp="1"/>
-          </p:cNvSpPr>
-          <p:nvPr userDrawn="1"/>
-        </p:nvSpPr>
-        <p:spPr>
-          <a:xfrm>
-            <a:off x="1058068" y="391026"/>
-            <a:ext cx="2221463" cy="442429"/>
-          </a:xfrm>
-          <a:prstGeom prst="rect">
-            <a:avLst/>
-          </a:prstGeom>
-        </p:spPr>
-        <p:txBody>
-          <a:bodyPr vert="horz" wrap="square" lIns="0" tIns="11430" rIns="0" bIns="0" rtlCol="0">
-            <a:spAutoFit/>
-          </a:bodyPr>
-          <a:lstStyle>
-            <a:lvl1pPr>
-              <a:defRPr sz="2950" b="1" i="0">
-                <a:solidFill>
-                  <a:srgbClr val="1B5FA7"/>
-                </a:solidFill>
-                <a:latin typeface="Calibri"/>
-                <a:ea typeface="+mj-ea"/>
-                <a:cs typeface="Calibri"/>
-              </a:defRPr>
-            </a:lvl1pPr>
-          </a:lstStyle>
-          <a:p>
-            <a:pPr marL="12700">
-              <a:lnSpc>
-                <a:spcPct val="100000"/>
-              </a:lnSpc>
-              <a:spcBef>
-                <a:spcPts val="90"/>
-              </a:spcBef>
-              <a:tabLst>
-                <a:tab pos="918844" algn="l"/>
-              </a:tabLst>
-            </a:pPr>
-            <a:r>
-              <a:rPr lang="es-ES" sz="2800" dirty="0"/>
-              <a:t>15.</a:t>
-            </a:r>
-            <a:r>
-              <a:rPr lang="es-ES" sz="2800" spc="-65" dirty="0"/>
-              <a:t> </a:t>
-            </a:r>
-            <a:r>
-              <a:rPr lang="es-ES" sz="2800" spc="-10" dirty="0"/>
-              <a:t>Novedades</a:t>
-            </a:r>
-            <a:endParaRPr sz="2800" spc="-10" dirty="0">
-              <a:solidFill>
-                <a:srgbClr val="1B5FA7"/>
-              </a:solidFill>
             </a:endParaRPr>
           </a:p>
         </p:txBody>
@@ -17033,10 +16914,10 @@
       </p:grpSpPr>
       <p:sp>
         <p:nvSpPr>
-          <p:cNvPr id="2" name="txtFecha">
+          <p:cNvPr id="3" name="txtFecha">
             <a:extLst>
               <a:ext uri="{FF2B5EF4-FFF2-40B4-BE49-F238E27FC236}">
-                <a16:creationId xmlns:a16="http://schemas.microsoft.com/office/drawing/2014/main" id="{47749C0C-BA9B-4C48-B76C-C15316BD7B23}"/>
+                <a16:creationId xmlns:a16="http://schemas.microsoft.com/office/drawing/2014/main" id="{31226ED0-A8AB-42D7-8683-04E604F294BD}"/>
               </a:ext>
             </a:extLst>
           </p:cNvPr>
@@ -17045,7 +16926,7 @@
         </p:nvSpPr>
         <p:spPr>
           <a:xfrm>
-            <a:off x="3584983" y="4085150"/>
+            <a:off x="3584983" y="3243789"/>
             <a:ext cx="5022034" cy="370422"/>
           </a:xfrm>
           <a:prstGeom prst="rect">
@@ -17126,10 +17007,10 @@
       </p:grpSpPr>
       <p:sp>
         <p:nvSpPr>
-          <p:cNvPr id="3" name="imgMarco-D10">
+          <p:cNvPr id="4" name="imgMarco-D10">
             <a:extLst>
               <a:ext uri="{FF2B5EF4-FFF2-40B4-BE49-F238E27FC236}">
-                <a16:creationId xmlns:a16="http://schemas.microsoft.com/office/drawing/2014/main" id="{1757AEB0-6C22-4C26-A433-A0354CEF7827}"/>
+                <a16:creationId xmlns:a16="http://schemas.microsoft.com/office/drawing/2014/main" id="{83B2BFF0-0900-4F3E-A1B4-3C22CC428E52}"/>
               </a:ext>
             </a:extLst>
           </p:cNvPr>
@@ -17138,8 +17019,8 @@
         </p:nvSpPr>
         <p:spPr>
           <a:xfrm>
-            <a:off x="1261586" y="2473697"/>
-            <a:ext cx="9668828" cy="1910607"/>
+            <a:off x="1261586" y="2218098"/>
+            <a:ext cx="9668828" cy="2439909"/>
           </a:xfrm>
           <a:prstGeom prst="rect">
             <a:avLst/>
@@ -17207,7 +17088,7 @@
           <p:cNvPr id="3" name="imgMarco-D11">
             <a:extLst>
               <a:ext uri="{FF2B5EF4-FFF2-40B4-BE49-F238E27FC236}">
-                <a16:creationId xmlns:a16="http://schemas.microsoft.com/office/drawing/2014/main" id="{E53836B4-7506-4CF9-B160-8234AD0AC9E8}"/>
+                <a16:creationId xmlns:a16="http://schemas.microsoft.com/office/drawing/2014/main" id="{E029353C-F550-4CA2-B4D5-28FCF560384D}"/>
               </a:ext>
             </a:extLst>
           </p:cNvPr>
@@ -17216,8 +17097,8 @@
         </p:nvSpPr>
         <p:spPr>
           <a:xfrm>
-            <a:off x="1261586" y="2258801"/>
-            <a:ext cx="9668828" cy="2340398"/>
+            <a:off x="1261586" y="1436460"/>
+            <a:ext cx="9668828" cy="4537530"/>
           </a:xfrm>
           <a:prstGeom prst="rect">
             <a:avLst/>
@@ -17282,10 +17163,10 @@
       </p:grpSpPr>
       <p:sp>
         <p:nvSpPr>
-          <p:cNvPr id="3" name="imgMarco-D12">
+          <p:cNvPr id="4" name="imgMarco-D12">
             <a:extLst>
               <a:ext uri="{FF2B5EF4-FFF2-40B4-BE49-F238E27FC236}">
-                <a16:creationId xmlns:a16="http://schemas.microsoft.com/office/drawing/2014/main" id="{5B404EAB-6E91-4357-9144-344A2F7F0361}"/>
+                <a16:creationId xmlns:a16="http://schemas.microsoft.com/office/drawing/2014/main" id="{2E87CD28-2E28-4F99-9C72-F84F566F759C}"/>
               </a:ext>
             </a:extLst>
           </p:cNvPr>
@@ -17294,8 +17175,8 @@
         </p:nvSpPr>
         <p:spPr>
           <a:xfrm>
-            <a:off x="1261586" y="1463256"/>
-            <a:ext cx="9668828" cy="3931488"/>
+            <a:off x="1261586" y="1436460"/>
+            <a:ext cx="9668828" cy="4537530"/>
           </a:xfrm>
           <a:prstGeom prst="rect">
             <a:avLst/>
@@ -17360,10 +17241,10 @@
       </p:grpSpPr>
       <p:sp>
         <p:nvSpPr>
-          <p:cNvPr id="3" name="imgMarco-D13">
+          <p:cNvPr id="4" name="imgMarco-D13">
             <a:extLst>
               <a:ext uri="{FF2B5EF4-FFF2-40B4-BE49-F238E27FC236}">
-                <a16:creationId xmlns:a16="http://schemas.microsoft.com/office/drawing/2014/main" id="{A7D1FACB-B5C1-4F7B-8931-F744C0C83212}"/>
+                <a16:creationId xmlns:a16="http://schemas.microsoft.com/office/drawing/2014/main" id="{3EB74E31-472E-4E8C-9790-FB736A9FE590}"/>
               </a:ext>
             </a:extLst>
           </p:cNvPr>
@@ -17372,8 +17253,8 @@
         </p:nvSpPr>
         <p:spPr>
           <a:xfrm>
-            <a:off x="1261586" y="1427105"/>
-            <a:ext cx="9668828" cy="4003791"/>
+            <a:off x="1261586" y="1436460"/>
+            <a:ext cx="9668828" cy="4537530"/>
           </a:xfrm>
           <a:prstGeom prst="rect">
             <a:avLst/>
@@ -17450,8 +17331,8 @@
         </p:nvSpPr>
         <p:spPr>
           <a:xfrm>
-            <a:off x="3231154" y="1896427"/>
-            <a:ext cx="5729692" cy="3065146"/>
+            <a:off x="3917133" y="1896427"/>
+            <a:ext cx="4357734" cy="3065146"/>
           </a:xfrm>
           <a:prstGeom prst="rect">
             <a:avLst/>
@@ -17606,8 +17487,8 @@
         </p:nvSpPr>
         <p:spPr>
           <a:xfrm>
-            <a:off x="1233487" y="2433638"/>
-            <a:ext cx="9725026" cy="1990725"/>
+            <a:off x="1233487" y="1652258"/>
+            <a:ext cx="9725026" cy="3553484"/>
           </a:xfrm>
           <a:prstGeom prst="rect">
             <a:avLst/>
@@ -17996,8 +17877,8 @@
         </p:nvSpPr>
         <p:spPr>
           <a:xfrm>
-            <a:off x="4197413" y="2192760"/>
-            <a:ext cx="3797174" cy="2613152"/>
+            <a:off x="4043362" y="2329173"/>
+            <a:ext cx="4105276" cy="3123102"/>
           </a:xfrm>
           <a:prstGeom prst="rect">
             <a:avLst/>
@@ -18386,8 +18267,8 @@
         </p:nvSpPr>
         <p:spPr>
           <a:xfrm>
-            <a:off x="1177619" y="2595764"/>
-            <a:ext cx="9839144" cy="1666472"/>
+            <a:off x="1176428" y="1982709"/>
+            <a:ext cx="9839144" cy="2892582"/>
           </a:xfrm>
           <a:prstGeom prst="rect">
             <a:avLst/>
@@ -18450,6 +18331,108 @@
           <a:chExt cx="0" cy="0"/>
         </a:xfrm>
       </p:grpSpPr>
+      <p:sp>
+        <p:nvSpPr>
+          <p:cNvPr id="2" name="txt-D26">
+            <a:extLst>
+              <a:ext uri="{FF2B5EF4-FFF2-40B4-BE49-F238E27FC236}">
+                <a16:creationId xmlns:a16="http://schemas.microsoft.com/office/drawing/2014/main" id="{644E8410-ABAA-43B6-B897-36186296A1A2}"/>
+              </a:ext>
+            </a:extLst>
+          </p:cNvPr>
+          <p:cNvSpPr/>
+          <p:nvPr/>
+        </p:nvSpPr>
+        <p:spPr>
+          <a:xfrm>
+            <a:off x="1062952" y="1315946"/>
+            <a:ext cx="5033048" cy="369332"/>
+          </a:xfrm>
+          <a:prstGeom prst="rect">
+            <a:avLst/>
+          </a:prstGeom>
+        </p:spPr>
+        <p:txBody>
+          <a:bodyPr wrap="square">
+            <a:spAutoFit/>
+          </a:bodyPr>
+          <a:lstStyle/>
+          <a:p>
+            <a:endParaRPr lang="es-CO" dirty="0"/>
+          </a:p>
+        </p:txBody>
+      </p:sp>
+      <p:sp>
+        <p:nvSpPr>
+          <p:cNvPr id="3" name="titulo-D26">
+            <a:extLst>
+              <a:ext uri="{FF2B5EF4-FFF2-40B4-BE49-F238E27FC236}">
+                <a16:creationId xmlns:a16="http://schemas.microsoft.com/office/drawing/2014/main" id="{2C741CCC-F785-4A79-90E1-EBE05443B07F}"/>
+              </a:ext>
+            </a:extLst>
+          </p:cNvPr>
+          <p:cNvSpPr txBox="1">
+            <a:spLocks noGrp="1"/>
+          </p:cNvSpPr>
+          <p:nvPr/>
+        </p:nvSpPr>
+        <p:spPr>
+          <a:xfrm>
+            <a:off x="1058068" y="391026"/>
+            <a:ext cx="2221463" cy="442429"/>
+          </a:xfrm>
+          <a:prstGeom prst="rect">
+            <a:avLst/>
+          </a:prstGeom>
+        </p:spPr>
+        <p:txBody>
+          <a:bodyPr vert="horz" wrap="square" lIns="0" tIns="11430" rIns="0" bIns="0" rtlCol="0">
+            <a:spAutoFit/>
+          </a:bodyPr>
+          <a:lstStyle>
+            <a:lvl1pPr>
+              <a:defRPr sz="2950" b="1" i="0">
+                <a:solidFill>
+                  <a:srgbClr val="1B5FA7"/>
+                </a:solidFill>
+                <a:latin typeface="Calibri"/>
+                <a:ea typeface="+mj-ea"/>
+                <a:cs typeface="Calibri"/>
+              </a:defRPr>
+            </a:lvl1pPr>
+          </a:lstStyle>
+          <a:p>
+            <a:pPr marL="12700">
+              <a:lnSpc>
+                <a:spcPct val="100000"/>
+              </a:lnSpc>
+              <a:spcBef>
+                <a:spcPts val="90"/>
+              </a:spcBef>
+              <a:tabLst>
+                <a:tab pos="918844" algn="l"/>
+              </a:tabLst>
+            </a:pPr>
+            <a:r>
+              <a:rPr lang="es-ES" sz="2800" dirty="0"/>
+              <a:t>15.</a:t>
+            </a:r>
+            <a:r>
+              <a:rPr lang="es-ES" sz="2800" spc="-65" dirty="0"/>
+              <a:t> </a:t>
+            </a:r>
+            <a:r>
+              <a:rPr lang="es-ES" sz="2800" spc="-10" dirty="0"/>
+              <a:t>Novedades</a:t>
+            </a:r>
+            <a:endParaRPr sz="2800" spc="-10" dirty="0">
+              <a:solidFill>
+                <a:srgbClr val="1B5FA7"/>
+              </a:solidFill>
+            </a:endParaRPr>
+          </a:p>
+        </p:txBody>
+      </p:sp>
     </p:spTree>
     <p:extLst>
       <p:ext uri="{BB962C8B-B14F-4D97-AF65-F5344CB8AC3E}">
@@ -19294,8 +19277,8 @@
         </p:nvSpPr>
         <p:spPr>
           <a:xfrm>
-            <a:off x="1261586" y="2573265"/>
-            <a:ext cx="9668828" cy="1711471"/>
+            <a:off x="1261586" y="2218098"/>
+            <a:ext cx="9668828" cy="2439909"/>
           </a:xfrm>
           <a:prstGeom prst="rect">
             <a:avLst/>
@@ -19360,10 +19343,10 @@
       </p:grpSpPr>
       <p:sp>
         <p:nvSpPr>
-          <p:cNvPr id="2" name="imgMarco-D9-1">
+          <p:cNvPr id="4" name="imgMarco-D9-1">
             <a:extLst>
               <a:ext uri="{FF2B5EF4-FFF2-40B4-BE49-F238E27FC236}">
-                <a16:creationId xmlns:a16="http://schemas.microsoft.com/office/drawing/2014/main" id="{39F5A094-6E80-42EC-9BD5-AF8D12A8F6C4}"/>
+                <a16:creationId xmlns:a16="http://schemas.microsoft.com/office/drawing/2014/main" id="{672F2363-318A-45C3-9CF0-0D4BB586F21E}"/>
               </a:ext>
             </a:extLst>
           </p:cNvPr>
@@ -19372,8 +19355,8 @@
         </p:nvSpPr>
         <p:spPr>
           <a:xfrm>
-            <a:off x="1198684" y="1436460"/>
-            <a:ext cx="5510091" cy="4537530"/>
+            <a:off x="1198685" y="1436460"/>
+            <a:ext cx="5473578" cy="4537530"/>
           </a:xfrm>
           <a:prstGeom prst="rect">
             <a:avLst/>
@@ -19408,10 +19391,10 @@
       </p:sp>
       <p:sp>
         <p:nvSpPr>
-          <p:cNvPr id="3" name="imgMarco-D9-2">
+          <p:cNvPr id="5" name="imgMarco-D9-2">
             <a:extLst>
               <a:ext uri="{FF2B5EF4-FFF2-40B4-BE49-F238E27FC236}">
-                <a16:creationId xmlns:a16="http://schemas.microsoft.com/office/drawing/2014/main" id="{CF6B7B07-901B-4A7E-8C0B-D20A66F47ED8}"/>
+                <a16:creationId xmlns:a16="http://schemas.microsoft.com/office/drawing/2014/main" id="{FE5C6CD3-727C-40EB-BD1D-FD2B62024560}"/>
               </a:ext>
             </a:extLst>
           </p:cNvPr>
@@ -19420,8 +19403,8 @@
         </p:nvSpPr>
         <p:spPr>
           <a:xfrm>
-            <a:off x="6851650" y="1436460"/>
-            <a:ext cx="4141666" cy="4537530"/>
+            <a:off x="6735777" y="1988910"/>
+            <a:ext cx="4400535" cy="3432630"/>
           </a:xfrm>
           <a:prstGeom prst="rect">
             <a:avLst/>

</xml_diff>

<commit_message>
Mejoras UI: Mejora al traer nombres de responsables y Mejora en interfaz
</commit_message>
<xml_diff>
--- a/dist/plantilla-2pm.pptx
+++ b/dist/plantilla-2pm.pptx
@@ -255,7 +255,7 @@
           <a:p>
             <a:fld id="{631855BB-C5D2-4F82-B71B-CB3B65D6AB2E}" type="datetimeFigureOut">
               <a:rPr lang="es-ES" smtClean="0"/>
-              <a:t>23/03/2026</a:t>
+              <a:t>01/04/2026</a:t>
             </a:fld>
             <a:endParaRPr lang="es-ES"/>
           </a:p>
@@ -17019,8 +17019,8 @@
         </p:nvSpPr>
         <p:spPr>
           <a:xfrm>
-            <a:off x="1261586" y="2218098"/>
-            <a:ext cx="9668828" cy="2439909"/>
+            <a:off x="1261586" y="2362955"/>
+            <a:ext cx="9668828" cy="2150196"/>
           </a:xfrm>
           <a:prstGeom prst="rect">
             <a:avLst/>

</xml_diff>